<commit_message>
Proposta Still Pet: remove o slide de titularidade e saída
A pedido do usuário. Removido em todos os pontos que o OOXML exige:
relationship em presentation.xml.rels, entrada no sldIdLst, overrides
no [Content_Types].xml e as partes slide10.xml, seu .rels, o
notesSlide10 correspondente e o .rels dele.

Numeração de página renumerada de /11 para /10 nos dez slides, já que
o rótulo é texto fixo e não se atualiza sozinho.

Validado: XML bem formado em todas as partes, nenhuma relationship
quebrada, nenhum override órfão.

Co-Authored-By: Claude Opus 5 <noreply@anthropic.com>
Claude-Session: https://claude.ai/code/session_017xRPoJqxsuGFv4VmDesebx
</commit_message>
<xml_diff>
--- a/stillpet/orig/Proposta-StillPet-Amazon-1P.pptx
+++ b/stillpet/orig/Proposta-StillPet-Amazon-1P.pptx
@@ -17,7 +17,6 @@
     <p:sldId id="262" r:id="rId11"/>
     <p:sldId id="263" r:id="rId12"/>
     <p:sldId id="264" r:id="rId13"/>
-    <p:sldId id="265" r:id="rId14"/>
     <p:sldId id="266" r:id="rId15"/>
   </p:sldIdLst>
   <p:sldSz cy="6858000" cx="12192000"/>
@@ -2096,543 +2095,6 @@
       <p:sp>
         <p:nvSpPr>
           <p:cNvPr id="14" name="Google Shape;14;p1:notes"/>
-          <p:cNvSpPr txBox="1"/>
-          <p:nvPr>
-            <p:ph idx="12" type="sldNum"/>
-          </p:nvPr>
-        </p:nvSpPr>
-        <p:spPr>
-          <a:xfrm>
-            <a:off x="0" y="0"/>
-            <a:ext cx="3000000" cy="3000000"/>
-          </a:xfrm>
-          <a:prstGeom prst="rect">
-            <a:avLst/>
-          </a:prstGeom>
-          <a:noFill/>
-          <a:ln>
-            <a:noFill/>
-          </a:ln>
-        </p:spPr>
-        <p:txBody>
-          <a:bodyPr anchorCtr="0" anchor="t" bIns="45700" lIns="91425" spcFirstLastPara="1" rIns="91425" wrap="square" tIns="45700">
-            <a:noAutofit/>
-          </a:bodyPr>
-          <a:lstStyle/>
-          <a:p>
-            <a:pPr indent="0" lvl="0" marL="0" rtl="0" algn="l">
-              <a:lnSpc>
-                <a:spcPct val="100000"/>
-              </a:lnSpc>
-              <a:spcBef>
-                <a:spcPts val="0"/>
-              </a:spcBef>
-              <a:spcAft>
-                <a:spcPts val="0"/>
-              </a:spcAft>
-              <a:buSzPts val="1400"/>
-              <a:buNone/>
-            </a:pPr>
-            <a:r>
-              <a:t/>
-            </a:r>
-            <a:endParaRPr/>
-          </a:p>
-        </p:txBody>
-      </p:sp>
-    </p:spTree>
-  </p:cSld>
-  <p:clrMapOvr>
-    <a:masterClrMapping/>
-  </p:clrMapOvr>
-</p:notes>
-</file>
-
-<file path=ppt/notesSlides/notesSlide10.xml><?xml version="1.0" encoding="utf-8"?>
-<p:notes xmlns:a="http://schemas.openxmlformats.org/drawingml/2006/main" xmlns:r="http://schemas.openxmlformats.org/officeDocument/2006/relationships" xmlns:mc="http://schemas.openxmlformats.org/markup-compatibility/2006" xmlns:mv="urn:schemas-microsoft-com:mac:vml" xmlns:p="http://schemas.openxmlformats.org/presentationml/2006/main" xmlns:c="http://schemas.openxmlformats.org/drawingml/2006/chart" xmlns:dgm="http://schemas.openxmlformats.org/drawingml/2006/diagram" xmlns:o="urn:schemas-microsoft-com:office:office" xmlns:v="urn:schemas-microsoft-com:vml" xmlns:pvml="urn:schemas-microsoft-com:office:powerpoint" xmlns:com="http://schemas.openxmlformats.org/drawingml/2006/compatibility" xmlns:p14="http://schemas.microsoft.com/office/powerpoint/2010/main" xmlns:p15="http://schemas.microsoft.com/office/powerpoint/2012/main" xmlns:ahyp="http://schemas.microsoft.com/office/drawing/2018/hyperlinkcolor" showMasterPhAnim="0" showMasterSp="0">
-  <p:cSld>
-    <p:spTree>
-      <p:nvGrpSpPr>
-        <p:cNvPr id="169" name="Shape 169"/>
-        <p:cNvGrpSpPr/>
-        <p:nvPr/>
-      </p:nvGrpSpPr>
-      <p:grpSpPr>
-        <a:xfrm>
-          <a:off x="0" y="0"/>
-          <a:ext cx="0" cy="0"/>
-          <a:chOff x="0" y="0"/>
-          <a:chExt cx="0" cy="0"/>
-        </a:xfrm>
-      </p:grpSpPr>
-      <p:sp>
-        <p:nvSpPr>
-          <p:cNvPr id="170" name="Google Shape;170;p14:notes"/>
-          <p:cNvSpPr/>
-          <p:nvPr>
-            <p:ph idx="2" type="sldImg"/>
-          </p:nvPr>
-        </p:nvSpPr>
-        <p:spPr>
-          <a:xfrm>
-            <a:off x="0" y="0"/>
-            <a:ext cx="3000000" cy="3000000"/>
-          </a:xfrm>
-          <a:custGeom>
-            <a:rect b="b" l="l" r="r" t="t"/>
-            <a:pathLst>
-              <a:path extrusionOk="0" h="120000" w="120000">
-                <a:moveTo>
-                  <a:pt x="0" y="0"/>
-                </a:moveTo>
-                <a:lnTo>
-                  <a:pt x="120000" y="0"/>
-                </a:lnTo>
-                <a:lnTo>
-                  <a:pt x="120000" y="120000"/>
-                </a:lnTo>
-                <a:lnTo>
-                  <a:pt x="0" y="120000"/>
-                </a:lnTo>
-                <a:close/>
-              </a:path>
-            </a:pathLst>
-          </a:custGeom>
-          <a:noFill/>
-          <a:ln>
-            <a:noFill/>
-          </a:ln>
-        </p:spPr>
-      </p:sp>
-      <p:sp>
-        <p:nvSpPr>
-          <p:cNvPr id="171" name="Google Shape;171;p14:notes"/>
-          <p:cNvSpPr txBox="1"/>
-          <p:nvPr>
-            <p:ph idx="1" type="body"/>
-          </p:nvPr>
-        </p:nvSpPr>
-        <p:spPr>
-          <a:xfrm>
-            <a:off x="0" y="0"/>
-            <a:ext cx="3000000" cy="3000000"/>
-          </a:xfrm>
-          <a:prstGeom prst="rect">
-            <a:avLst/>
-          </a:prstGeom>
-          <a:noFill/>
-          <a:ln>
-            <a:noFill/>
-          </a:ln>
-        </p:spPr>
-        <p:txBody>
-          <a:bodyPr anchorCtr="0" anchor="t" bIns="45700" lIns="91425" spcFirstLastPara="1" rIns="91425" wrap="square" tIns="45700">
-            <a:noAutofit/>
-          </a:bodyPr>
-          <a:lstStyle/>
-          <a:p>
-            <a:pPr indent="0" lvl="0" marL="0" rtl="0" algn="l">
-              <a:lnSpc>
-                <a:spcPct val="100000"/>
-              </a:lnSpc>
-              <a:spcBef>
-                <a:spcPts val="0"/>
-              </a:spcBef>
-              <a:spcAft>
-                <a:spcPts val="0"/>
-              </a:spcAft>
-              <a:buSzPts val="1400"/>
-              <a:buNone/>
-            </a:pPr>
-            <a:r>
-              <a:rPr lang="en-US" sz="1200"/>
-              <a:t>[Fontes] Evidências coletadas em amazon.com.br entre 22 e 23/09/2026 (prints de tela arquivados). Catálogo de 151 anúncios sob a marca Tudo Pet, verificado por busca de marca na Amazon Brasil. Escopo, prazos e valores conforme alinhado em reunião com a Still Pet. Nenhum número neste documento é estimativa: cada dado tem print datado. [/Fontes]</a:t>
-            </a:r>
-            <a:endParaRPr/>
-          </a:p>
-          <a:p>
-            <a:pPr indent="0" lvl="0" marL="0" rtl="0" algn="l">
-              <a:lnSpc>
-                <a:spcPct val="100000"/>
-              </a:lnSpc>
-              <a:spcBef>
-                <a:spcPts val="0"/>
-              </a:spcBef>
-              <a:spcAft>
-                <a:spcPts val="0"/>
-              </a:spcAft>
-              <a:buSzPts val="1400"/>
-              <a:buNone/>
-            </a:pPr>
-            <a:r>
-              <a:rPr lang="en-US" sz="1200"/>
-              <a:t/>
-            </a:r>
-            <a:endParaRPr/>
-          </a:p>
-          <a:p>
-            <a:pPr indent="0" lvl="0" marL="0" rtl="0" algn="l">
-              <a:lnSpc>
-                <a:spcPct val="100000"/>
-              </a:lnSpc>
-              <a:spcBef>
-                <a:spcPts val="0"/>
-              </a:spcBef>
-              <a:spcAft>
-                <a:spcPts val="0"/>
-              </a:spcAft>
-              <a:buSzPts val="1400"/>
-              <a:buNone/>
-            </a:pPr>
-            <a:r>
-              <a:t/>
-            </a:r>
-            <a:endParaRPr sz="1200"/>
-          </a:p>
-          <a:p>
-            <a:pPr indent="0" lvl="0" marL="0" rtl="0" algn="l">
-              <a:lnSpc>
-                <a:spcPct val="100000"/>
-              </a:lnSpc>
-              <a:spcBef>
-                <a:spcPts val="0"/>
-              </a:spcBef>
-              <a:spcAft>
-                <a:spcPts val="0"/>
-              </a:spcAft>
-              <a:buSzPts val="1400"/>
-              <a:buNone/>
-            </a:pPr>
-            <a:r>
-              <a:rPr lang="en-US" sz="1200"/>
-              <a:t/>
-            </a:r>
-            <a:endParaRPr/>
-          </a:p>
-          <a:p>
-            <a:pPr indent="0" lvl="0" marL="0" rtl="0" algn="l">
-              <a:lnSpc>
-                <a:spcPct val="100000"/>
-              </a:lnSpc>
-              <a:spcBef>
-                <a:spcPts val="0"/>
-              </a:spcBef>
-              <a:spcAft>
-                <a:spcPts val="0"/>
-              </a:spcAft>
-              <a:buSzPts val="1400"/>
-              <a:buNone/>
-            </a:pPr>
-            <a:r>
-              <a:rPr lang="en-US" sz="1200"/>
-              <a:t/>
-            </a:r>
-            <a:endParaRPr/>
-          </a:p>
-          <a:p>
-            <a:pPr indent="0" lvl="0" marL="0" rtl="0" algn="l">
-              <a:lnSpc>
-                <a:spcPct val="100000"/>
-              </a:lnSpc>
-              <a:spcBef>
-                <a:spcPts val="0"/>
-              </a:spcBef>
-              <a:spcAft>
-                <a:spcPts val="0"/>
-              </a:spcAft>
-              <a:buSzPts val="1400"/>
-              <a:buNone/>
-            </a:pPr>
-            <a:r>
-              <a:rPr lang="en-US" sz="1200"/>
-              <a:t/>
-            </a:r>
-            <a:endParaRPr/>
-          </a:p>
-          <a:p>
-            <a:pPr indent="0" lvl="0" marL="0" rtl="0" algn="l">
-              <a:lnSpc>
-                <a:spcPct val="100000"/>
-              </a:lnSpc>
-              <a:spcBef>
-                <a:spcPts val="0"/>
-              </a:spcBef>
-              <a:spcAft>
-                <a:spcPts val="0"/>
-              </a:spcAft>
-              <a:buSzPts val="1400"/>
-              <a:buNone/>
-            </a:pPr>
-            <a:r>
-              <a:rPr lang="en-US" sz="1200"/>
-              <a:t/>
-            </a:r>
-            <a:endParaRPr/>
-          </a:p>
-          <a:p>
-            <a:pPr indent="0" lvl="0" marL="0" rtl="0" algn="l">
-              <a:lnSpc>
-                <a:spcPct val="100000"/>
-              </a:lnSpc>
-              <a:spcBef>
-                <a:spcPts val="0"/>
-              </a:spcBef>
-              <a:spcAft>
-                <a:spcPts val="0"/>
-              </a:spcAft>
-              <a:buSzPts val="1400"/>
-              <a:buNone/>
-            </a:pPr>
-            <a:r>
-              <a:rPr lang="en-US" sz="1200"/>
-              <a:t/>
-            </a:r>
-            <a:endParaRPr/>
-          </a:p>
-          <a:p>
-            <a:pPr indent="0" lvl="0" marL="0" rtl="0" algn="l">
-              <a:lnSpc>
-                <a:spcPct val="100000"/>
-              </a:lnSpc>
-              <a:spcBef>
-                <a:spcPts val="0"/>
-              </a:spcBef>
-              <a:spcAft>
-                <a:spcPts val="0"/>
-              </a:spcAft>
-              <a:buSzPts val="1400"/>
-              <a:buNone/>
-            </a:pPr>
-            <a:r>
-              <a:rPr lang="en-US" sz="1200"/>
-              <a:t/>
-            </a:r>
-            <a:endParaRPr/>
-          </a:p>
-          <a:p>
-            <a:pPr indent="0" lvl="0" marL="0" rtl="0" algn="l">
-              <a:lnSpc>
-                <a:spcPct val="100000"/>
-              </a:lnSpc>
-              <a:spcBef>
-                <a:spcPts val="0"/>
-              </a:spcBef>
-              <a:spcAft>
-                <a:spcPts val="0"/>
-              </a:spcAft>
-              <a:buSzPts val="1400"/>
-              <a:buNone/>
-            </a:pPr>
-            <a:r>
-              <a:rPr lang="en-US" sz="1200"/>
-              <a:t/>
-            </a:r>
-            <a:endParaRPr/>
-          </a:p>
-          <a:p>
-            <a:pPr indent="0" lvl="0" marL="0" rtl="0" algn="l">
-              <a:lnSpc>
-                <a:spcPct val="100000"/>
-              </a:lnSpc>
-              <a:spcBef>
-                <a:spcPts val="0"/>
-              </a:spcBef>
-              <a:spcAft>
-                <a:spcPts val="0"/>
-              </a:spcAft>
-              <a:buSzPts val="1400"/>
-              <a:buNone/>
-            </a:pPr>
-            <a:r>
-              <a:rPr lang="en-US" sz="1200"/>
-              <a:t/>
-            </a:r>
-            <a:endParaRPr/>
-          </a:p>
-          <a:p>
-            <a:pPr indent="0" lvl="0" marL="0" rtl="0" algn="l">
-              <a:lnSpc>
-                <a:spcPct val="100000"/>
-              </a:lnSpc>
-              <a:spcBef>
-                <a:spcPts val="0"/>
-              </a:spcBef>
-              <a:spcAft>
-                <a:spcPts val="0"/>
-              </a:spcAft>
-              <a:buSzPts val="1400"/>
-              <a:buNone/>
-            </a:pPr>
-            <a:r>
-              <a:rPr lang="en-US" sz="1200"/>
-              <a:t/>
-            </a:r>
-            <a:endParaRPr/>
-          </a:p>
-          <a:p>
-            <a:pPr indent="0" lvl="0" marL="0" rtl="0" algn="l">
-              <a:lnSpc>
-                <a:spcPct val="100000"/>
-              </a:lnSpc>
-              <a:spcBef>
-                <a:spcPts val="0"/>
-              </a:spcBef>
-              <a:spcAft>
-                <a:spcPts val="0"/>
-              </a:spcAft>
-              <a:buSzPts val="1400"/>
-              <a:buNone/>
-            </a:pPr>
-            <a:r>
-              <a:rPr lang="en-US" sz="1200"/>
-              <a:t/>
-            </a:r>
-            <a:endParaRPr/>
-          </a:p>
-          <a:p>
-            <a:pPr indent="0" lvl="0" marL="0" rtl="0" algn="l">
-              <a:lnSpc>
-                <a:spcPct val="100000"/>
-              </a:lnSpc>
-              <a:spcBef>
-                <a:spcPts val="0"/>
-              </a:spcBef>
-              <a:spcAft>
-                <a:spcPts val="0"/>
-              </a:spcAft>
-              <a:buSzPts val="1400"/>
-              <a:buNone/>
-            </a:pPr>
-            <a:r>
-              <a:t/>
-            </a:r>
-            <a:endParaRPr sz="1200"/>
-          </a:p>
-          <a:p>
-            <a:pPr indent="0" lvl="0" marL="0" rtl="0" algn="l">
-              <a:lnSpc>
-                <a:spcPct val="100000"/>
-              </a:lnSpc>
-              <a:spcBef>
-                <a:spcPts val="0"/>
-              </a:spcBef>
-              <a:spcAft>
-                <a:spcPts val="0"/>
-              </a:spcAft>
-              <a:buSzPts val="1400"/>
-              <a:buNone/>
-            </a:pPr>
-            <a:r>
-              <a:rPr lang="en-US" sz="1200"/>
-              <a:t/>
-            </a:r>
-            <a:endParaRPr/>
-          </a:p>
-          <a:p>
-            <a:pPr indent="0" lvl="0" marL="0" rtl="0" algn="l">
-              <a:lnSpc>
-                <a:spcPct val="100000"/>
-              </a:lnSpc>
-              <a:spcBef>
-                <a:spcPts val="0"/>
-              </a:spcBef>
-              <a:spcAft>
-                <a:spcPts val="0"/>
-              </a:spcAft>
-              <a:buSzPts val="1400"/>
-              <a:buNone/>
-            </a:pPr>
-            <a:r>
-              <a:rPr lang="en-US" sz="1200"/>
-              <a:t/>
-            </a:r>
-            <a:endParaRPr/>
-          </a:p>
-          <a:p>
-            <a:pPr indent="0" lvl="0" marL="0" rtl="0" algn="l">
-              <a:lnSpc>
-                <a:spcPct val="100000"/>
-              </a:lnSpc>
-              <a:spcBef>
-                <a:spcPts val="0"/>
-              </a:spcBef>
-              <a:spcAft>
-                <a:spcPts val="0"/>
-              </a:spcAft>
-              <a:buSzPts val="1400"/>
-              <a:buNone/>
-            </a:pPr>
-            <a:r>
-              <a:rPr lang="en-US" sz="1200"/>
-              <a:t/>
-            </a:r>
-            <a:endParaRPr/>
-          </a:p>
-          <a:p>
-            <a:pPr indent="0" lvl="0" marL="0" rtl="0" algn="l">
-              <a:lnSpc>
-                <a:spcPct val="100000"/>
-              </a:lnSpc>
-              <a:spcBef>
-                <a:spcPts val="0"/>
-              </a:spcBef>
-              <a:spcAft>
-                <a:spcPts val="0"/>
-              </a:spcAft>
-              <a:buSzPts val="1400"/>
-              <a:buNone/>
-            </a:pPr>
-            <a:r>
-              <a:rPr lang="en-US" sz="1200"/>
-              <a:t/>
-            </a:r>
-            <a:endParaRPr/>
-          </a:p>
-          <a:p>
-            <a:pPr indent="0" lvl="0" marL="0" rtl="0" algn="l">
-              <a:lnSpc>
-                <a:spcPct val="100000"/>
-              </a:lnSpc>
-              <a:spcBef>
-                <a:spcPts val="0"/>
-              </a:spcBef>
-              <a:spcAft>
-                <a:spcPts val="0"/>
-              </a:spcAft>
-              <a:buSzPts val="1400"/>
-              <a:buNone/>
-            </a:pPr>
-            <a:r>
-              <a:rPr lang="en-US" sz="1200"/>
-              <a:t/>
-            </a:r>
-            <a:endParaRPr/>
-          </a:p>
-          <a:p>
-            <a:pPr indent="0" lvl="0" marL="0" rtl="0" algn="l">
-              <a:lnSpc>
-                <a:spcPct val="100000"/>
-              </a:lnSpc>
-              <a:spcBef>
-                <a:spcPts val="0"/>
-              </a:spcBef>
-              <a:spcAft>
-                <a:spcPts val="0"/>
-              </a:spcAft>
-              <a:buSzPts val="1400"/>
-              <a:buNone/>
-            </a:pPr>
-            <a:r>
-              <a:rPr lang="en-US" sz="1200"/>
-              <a:t/>
-            </a:r>
-            <a:endParaRPr/>
-          </a:p>
-        </p:txBody>
-      </p:sp>
-      <p:sp>
-        <p:nvSpPr>
-          <p:cNvPr id="172" name="Google Shape;172;p14:notes"/>
           <p:cNvSpPr txBox="1"/>
           <p:nvPr>
             <p:ph idx="12" type="sldNum"/>
@@ -9562,7 +9024,7 @@
                 <a:cs typeface="JetBrains Mono"/>
                 <a:sym typeface="JetBrains Mono"/>
               </a:rPr>
-              <a:t>01 / 11</a:t>
+              <a:t>01 / 10</a:t>
             </a:r>
             <a:endParaRPr b="0" i="0" sz="1400" u="none" cap="none" strike="noStrike">
               <a:solidFill>
@@ -9950,732 +9412,6 @@
               <a:ea typeface="Space Grotesk"/>
               <a:cs typeface="Space Grotesk"/>
               <a:sym typeface="Space Grotesk"/>
-            </a:endParaRPr>
-          </a:p>
-        </p:txBody>
-      </p:sp>
-    </p:spTree>
-  </p:cSld>
-  <p:clrMapOvr>
-    <a:masterClrMapping/>
-  </p:clrMapOvr>
-</p:sld>
-</file>
-
-<file path=ppt/slides/slide10.xml><?xml version="1.0" encoding="utf-8"?>
-<p:sld xmlns:a="http://schemas.openxmlformats.org/drawingml/2006/main" xmlns:r="http://schemas.openxmlformats.org/officeDocument/2006/relationships" xmlns:mc="http://schemas.openxmlformats.org/markup-compatibility/2006" xmlns:mv="urn:schemas-microsoft-com:mac:vml" xmlns:p="http://schemas.openxmlformats.org/presentationml/2006/main" xmlns:c="http://schemas.openxmlformats.org/drawingml/2006/chart" xmlns:dgm="http://schemas.openxmlformats.org/drawingml/2006/diagram" xmlns:o="urn:schemas-microsoft-com:office:office" xmlns:v="urn:schemas-microsoft-com:vml" xmlns:pvml="urn:schemas-microsoft-com:office:powerpoint" xmlns:com="http://schemas.openxmlformats.org/drawingml/2006/compatibility" xmlns:p14="http://schemas.microsoft.com/office/powerpoint/2010/main" xmlns:p15="http://schemas.microsoft.com/office/powerpoint/2012/main" xmlns:ahyp="http://schemas.microsoft.com/office/drawing/2018/hyperlinkcolor">
-  <p:cSld>
-    <p:spTree>
-      <p:nvGrpSpPr>
-        <p:cNvPr id="173" name="Shape 173"/>
-        <p:cNvGrpSpPr/>
-        <p:nvPr/>
-      </p:nvGrpSpPr>
-      <p:grpSpPr>
-        <a:xfrm>
-          <a:off x="0" y="0"/>
-          <a:ext cx="0" cy="0"/>
-          <a:chOff x="0" y="0"/>
-          <a:chExt cx="0" cy="0"/>
-        </a:xfrm>
-      </p:grpSpPr>
-      <p:pic>
-        <p:nvPicPr>
-          <p:cNvPr id="174" name="Google Shape;174;p14"/>
-          <p:cNvPicPr preferRelativeResize="0"/>
-          <p:nvPr/>
-        </p:nvPicPr>
-        <p:blipFill rotWithShape="1">
-          <a:blip r:embed="rId3">
-            <a:alphaModFix/>
-          </a:blip>
-          <a:srcRect b="0" l="0" r="0" t="0"/>
-          <a:stretch/>
-        </p:blipFill>
-        <p:spPr>
-          <a:xfrm>
-            <a:off x="0" y="0"/>
-            <a:ext cx="12192000" cy="6858000"/>
-          </a:xfrm>
-          <a:prstGeom prst="rect">
-            <a:avLst/>
-          </a:prstGeom>
-          <a:noFill/>
-          <a:ln>
-            <a:noFill/>
-          </a:ln>
-        </p:spPr>
-      </p:pic>
-      <p:sp>
-        <p:nvSpPr>
-          <p:cNvPr id="175" name="Google Shape;175;p14"/>
-          <p:cNvSpPr/>
-          <p:nvPr/>
-        </p:nvSpPr>
-        <p:spPr>
-          <a:xfrm>
-            <a:off x="762000" y="542925"/>
-            <a:ext cx="8953500" cy="171450"/>
-          </a:xfrm>
-          <a:prstGeom prst="rect">
-            <a:avLst/>
-          </a:prstGeom>
-          <a:noFill/>
-          <a:ln>
-            <a:noFill/>
-          </a:ln>
-        </p:spPr>
-        <p:txBody>
-          <a:bodyPr anchorCtr="0" anchor="t" bIns="0" lIns="0" spcFirstLastPara="1" rIns="0" wrap="square" tIns="0">
-            <a:noAutofit/>
-          </a:bodyPr>
-          <a:lstStyle/>
-          <a:p>
-            <a:pPr indent="0" lvl="0" marL="0" marR="0" rtl="0" algn="l">
-              <a:lnSpc>
-                <a:spcPct val="100000"/>
-              </a:lnSpc>
-              <a:spcBef>
-                <a:spcPts val="0"/>
-              </a:spcBef>
-              <a:spcAft>
-                <a:spcPts val="0"/>
-              </a:spcAft>
-              <a:buClr>
-                <a:srgbClr val="69A7FF"/>
-              </a:buClr>
-              <a:buSzPts val="1350"/>
-              <a:buFont typeface="JetBrains Mono"/>
-              <a:buNone/>
-            </a:pPr>
-            <a:r>
-              <a:rPr b="0" i="0" lang="en-US" sz="1350" u="none" cap="none" strike="noStrike">
-                <a:solidFill>
-                  <a:srgbClr val="69A7FF"/>
-                </a:solidFill>
-                <a:latin typeface="JetBrains Mono"/>
-                <a:ea typeface="JetBrains Mono"/>
-                <a:cs typeface="JetBrains Mono"/>
-                <a:sym typeface="JetBrains Mono"/>
-              </a:rPr>
-              <a:t>TITULARIDADE E SAÍDA</a:t>
-            </a:r>
-            <a:endParaRPr b="0" i="0" sz="1400" u="none" cap="none" strike="noStrike">
-              <a:solidFill>
-                <a:srgbClr val="000000"/>
-              </a:solidFill>
-              <a:latin typeface="Arial"/>
-              <a:ea typeface="Arial"/>
-              <a:cs typeface="Arial"/>
-              <a:sym typeface="Arial"/>
-            </a:endParaRPr>
-          </a:p>
-        </p:txBody>
-      </p:sp>
-      <p:sp>
-        <p:nvSpPr>
-          <p:cNvPr id="176" name="Google Shape;176;p14"/>
-          <p:cNvSpPr/>
-          <p:nvPr/>
-        </p:nvSpPr>
-        <p:spPr>
-          <a:xfrm>
-            <a:off x="10572750" y="542925"/>
-            <a:ext cx="952500" cy="171450"/>
-          </a:xfrm>
-          <a:prstGeom prst="rect">
-            <a:avLst/>
-          </a:prstGeom>
-          <a:noFill/>
-          <a:ln>
-            <a:noFill/>
-          </a:ln>
-        </p:spPr>
-        <p:txBody>
-          <a:bodyPr anchorCtr="0" anchor="t" bIns="0" lIns="0" spcFirstLastPara="1" rIns="0" wrap="square" tIns="0">
-            <a:noAutofit/>
-          </a:bodyPr>
-          <a:lstStyle/>
-          <a:p>
-            <a:pPr indent="0" lvl="0" marL="0" marR="0" rtl="0" algn="l">
-              <a:lnSpc>
-                <a:spcPct val="100000"/>
-              </a:lnSpc>
-              <a:spcBef>
-                <a:spcPts val="0"/>
-              </a:spcBef>
-              <a:spcAft>
-                <a:spcPts val="0"/>
-              </a:spcAft>
-              <a:buClr>
-                <a:srgbClr val="C3CCDB"/>
-              </a:buClr>
-              <a:buSzPts val="1350"/>
-              <a:buFont typeface="JetBrains Mono"/>
-              <a:buNone/>
-            </a:pPr>
-            <a:r>
-              <a:rPr b="0" i="0" lang="en-US" sz="1350" u="none" cap="none" strike="noStrike">
-                <a:solidFill>
-                  <a:srgbClr val="C3CCDB"/>
-                </a:solidFill>
-                <a:latin typeface="JetBrains Mono"/>
-                <a:ea typeface="JetBrains Mono"/>
-                <a:cs typeface="JetBrains Mono"/>
-                <a:sym typeface="JetBrains Mono"/>
-              </a:rPr>
-              <a:t>10 / 11</a:t>
-            </a:r>
-            <a:endParaRPr b="0" i="0" sz="1400" u="none" cap="none" strike="noStrike">
-              <a:solidFill>
-                <a:srgbClr val="000000"/>
-              </a:solidFill>
-              <a:latin typeface="Arial"/>
-              <a:ea typeface="Arial"/>
-              <a:cs typeface="Arial"/>
-              <a:sym typeface="Arial"/>
-            </a:endParaRPr>
-          </a:p>
-        </p:txBody>
-      </p:sp>
-      <p:sp>
-        <p:nvSpPr>
-          <p:cNvPr id="177" name="Google Shape;177;p14"/>
-          <p:cNvSpPr/>
-          <p:nvPr/>
-        </p:nvSpPr>
-        <p:spPr>
-          <a:xfrm>
-            <a:off x="762000" y="1066800"/>
-            <a:ext cx="10668000" cy="971550"/>
-          </a:xfrm>
-          <a:prstGeom prst="rect">
-            <a:avLst/>
-          </a:prstGeom>
-          <a:noFill/>
-          <a:ln>
-            <a:noFill/>
-          </a:ln>
-        </p:spPr>
-        <p:txBody>
-          <a:bodyPr anchorCtr="0" anchor="t" bIns="0" lIns="0" spcFirstLastPara="1" rIns="0" wrap="square" tIns="0">
-            <a:noAutofit/>
-          </a:bodyPr>
-          <a:lstStyle/>
-          <a:p>
-            <a:pPr indent="0" lvl="0" marL="0" marR="0" rtl="0" algn="l">
-              <a:lnSpc>
-                <a:spcPct val="100000"/>
-              </a:lnSpc>
-              <a:spcBef>
-                <a:spcPts val="0"/>
-              </a:spcBef>
-              <a:spcAft>
-                <a:spcPts val="0"/>
-              </a:spcAft>
-              <a:buClr>
-                <a:srgbClr val="F1F2F8"/>
-              </a:buClr>
-              <a:buSzPts val="3825"/>
-              <a:buFont typeface="Space Grotesk"/>
-              <a:buNone/>
-            </a:pPr>
-            <a:r>
-              <a:rPr b="1" i="0" lang="en-US" sz="3825" u="none" cap="none" strike="noStrike">
-                <a:solidFill>
-                  <a:srgbClr val="F1F2F8"/>
-                </a:solidFill>
-                <a:latin typeface="Space Grotesk"/>
-                <a:ea typeface="Space Grotesk"/>
-                <a:cs typeface="Space Grotesk"/>
-                <a:sym typeface="Space Grotesk"/>
-              </a:rPr>
-              <a:t>Tudo que for construído</a:t>
-            </a:r>
-            <a:endParaRPr b="0" i="0" sz="1400" u="none" cap="none" strike="noStrike">
-              <a:solidFill>
-                <a:srgbClr val="000000"/>
-              </a:solidFill>
-              <a:latin typeface="Arial"/>
-              <a:ea typeface="Arial"/>
-              <a:cs typeface="Arial"/>
-              <a:sym typeface="Arial"/>
-            </a:endParaRPr>
-          </a:p>
-          <a:p>
-            <a:pPr indent="0" lvl="0" marL="0" marR="0" rtl="0" algn="l">
-              <a:lnSpc>
-                <a:spcPct val="100000"/>
-              </a:lnSpc>
-              <a:spcBef>
-                <a:spcPts val="0"/>
-              </a:spcBef>
-              <a:spcAft>
-                <a:spcPts val="0"/>
-              </a:spcAft>
-              <a:buClr>
-                <a:srgbClr val="F1F2F8"/>
-              </a:buClr>
-              <a:buSzPts val="3825"/>
-              <a:buFont typeface="Space Grotesk"/>
-              <a:buNone/>
-            </a:pPr>
-            <a:r>
-              <a:rPr b="1" i="0" lang="en-US" sz="3825" u="none" cap="none" strike="noStrike">
-                <a:solidFill>
-                  <a:srgbClr val="F1F2F8"/>
-                </a:solidFill>
-                <a:latin typeface="Space Grotesk"/>
-                <a:ea typeface="Space Grotesk"/>
-                <a:cs typeface="Space Grotesk"/>
-                <a:sym typeface="Space Grotesk"/>
-              </a:rPr>
-              <a:t>é de vocês.</a:t>
-            </a:r>
-            <a:endParaRPr b="0" i="0" sz="1400" u="none" cap="none" strike="noStrike">
-              <a:solidFill>
-                <a:srgbClr val="000000"/>
-              </a:solidFill>
-              <a:latin typeface="Arial"/>
-              <a:ea typeface="Arial"/>
-              <a:cs typeface="Arial"/>
-              <a:sym typeface="Arial"/>
-            </a:endParaRPr>
-          </a:p>
-        </p:txBody>
-      </p:sp>
-      <p:sp>
-        <p:nvSpPr>
-          <p:cNvPr id="178" name="Google Shape;178;p14"/>
-          <p:cNvSpPr/>
-          <p:nvPr/>
-        </p:nvSpPr>
-        <p:spPr>
-          <a:xfrm>
-            <a:off x="762000" y="2867025"/>
-            <a:ext cx="1952625" cy="171450"/>
-          </a:xfrm>
-          <a:prstGeom prst="rect">
-            <a:avLst/>
-          </a:prstGeom>
-          <a:noFill/>
-          <a:ln>
-            <a:noFill/>
-          </a:ln>
-        </p:spPr>
-        <p:txBody>
-          <a:bodyPr anchorCtr="0" anchor="t" bIns="0" lIns="0" spcFirstLastPara="1" rIns="0" wrap="square" tIns="0">
-            <a:noAutofit/>
-          </a:bodyPr>
-          <a:lstStyle/>
-          <a:p>
-            <a:pPr indent="0" lvl="0" marL="0" marR="0" rtl="0" algn="l">
-              <a:lnSpc>
-                <a:spcPct val="100000"/>
-              </a:lnSpc>
-              <a:spcBef>
-                <a:spcPts val="0"/>
-              </a:spcBef>
-              <a:spcAft>
-                <a:spcPts val="0"/>
-              </a:spcAft>
-              <a:buClr>
-                <a:srgbClr val="B5CBF5"/>
-              </a:buClr>
-              <a:buSzPts val="1350"/>
-              <a:buFont typeface="JetBrains Mono"/>
-              <a:buNone/>
-            </a:pPr>
-            <a:r>
-              <a:rPr b="0" i="0" lang="en-US" sz="1350" u="none" cap="none" strike="noStrike">
-                <a:solidFill>
-                  <a:srgbClr val="B5CBF5"/>
-                </a:solidFill>
-                <a:latin typeface="JetBrains Mono"/>
-                <a:ea typeface="JetBrains Mono"/>
-                <a:cs typeface="JetBrains Mono"/>
-                <a:sym typeface="JetBrains Mono"/>
-              </a:rPr>
-              <a:t>DURANTE</a:t>
-            </a:r>
-            <a:endParaRPr b="0" i="0" sz="1400" u="none" cap="none" strike="noStrike">
-              <a:solidFill>
-                <a:srgbClr val="000000"/>
-              </a:solidFill>
-              <a:latin typeface="Arial"/>
-              <a:ea typeface="Arial"/>
-              <a:cs typeface="Arial"/>
-              <a:sym typeface="Arial"/>
-            </a:endParaRPr>
-          </a:p>
-        </p:txBody>
-      </p:sp>
-      <p:sp>
-        <p:nvSpPr>
-          <p:cNvPr id="179" name="Google Shape;179;p14"/>
-          <p:cNvSpPr/>
-          <p:nvPr/>
-        </p:nvSpPr>
-        <p:spPr>
-          <a:xfrm>
-            <a:off x="3143250" y="2686050"/>
-            <a:ext cx="8286750" cy="628650"/>
-          </a:xfrm>
-          <a:prstGeom prst="rect">
-            <a:avLst/>
-          </a:prstGeom>
-          <a:noFill/>
-          <a:ln>
-            <a:noFill/>
-          </a:ln>
-        </p:spPr>
-        <p:txBody>
-          <a:bodyPr anchorCtr="0" anchor="t" bIns="0" lIns="0" spcFirstLastPara="1" rIns="0" wrap="square" tIns="0">
-            <a:noAutofit/>
-          </a:bodyPr>
-          <a:lstStyle/>
-          <a:p>
-            <a:pPr indent="0" lvl="0" marL="0" marR="0" rtl="0" algn="l">
-              <a:lnSpc>
-                <a:spcPct val="100000"/>
-              </a:lnSpc>
-              <a:spcBef>
-                <a:spcPts val="0"/>
-              </a:spcBef>
-              <a:spcAft>
-                <a:spcPts val="0"/>
-              </a:spcAft>
-              <a:buClr>
-                <a:srgbClr val="F1F2F8"/>
-              </a:buClr>
-              <a:buSzPts val="4950"/>
-              <a:buFont typeface="Space Grotesk"/>
-              <a:buNone/>
-            </a:pPr>
-            <a:r>
-              <a:rPr b="1" i="0" lang="en-US" sz="4950" u="none" cap="none" strike="noStrike">
-                <a:solidFill>
-                  <a:srgbClr val="F1F2F8"/>
-                </a:solidFill>
-                <a:latin typeface="Space Grotesk"/>
-                <a:ea typeface="Space Grotesk"/>
-                <a:cs typeface="Space Grotesk"/>
-                <a:sym typeface="Space Grotesk"/>
-              </a:rPr>
-              <a:t>A conta é da Still Pet</a:t>
-            </a:r>
-            <a:endParaRPr b="0" i="0" sz="1400" u="none" cap="none" strike="noStrike">
-              <a:solidFill>
-                <a:srgbClr val="000000"/>
-              </a:solidFill>
-              <a:latin typeface="Arial"/>
-              <a:ea typeface="Arial"/>
-              <a:cs typeface="Arial"/>
-              <a:sym typeface="Arial"/>
-            </a:endParaRPr>
-          </a:p>
-        </p:txBody>
-      </p:sp>
-      <p:sp>
-        <p:nvSpPr>
-          <p:cNvPr id="180" name="Google Shape;180;p14"/>
-          <p:cNvSpPr/>
-          <p:nvPr/>
-        </p:nvSpPr>
-        <p:spPr>
-          <a:xfrm>
-            <a:off x="3181350" y="3476625"/>
-            <a:ext cx="8248650" cy="247650"/>
-          </a:xfrm>
-          <a:prstGeom prst="rect">
-            <a:avLst/>
-          </a:prstGeom>
-          <a:noFill/>
-          <a:ln>
-            <a:noFill/>
-          </a:ln>
-        </p:spPr>
-        <p:txBody>
-          <a:bodyPr anchorCtr="0" anchor="t" bIns="0" lIns="0" spcFirstLastPara="1" rIns="0" wrap="square" tIns="0">
-            <a:noAutofit/>
-          </a:bodyPr>
-          <a:lstStyle/>
-          <a:p>
-            <a:pPr indent="0" lvl="0" marL="0" marR="0" rtl="0" algn="l">
-              <a:lnSpc>
-                <a:spcPct val="100000"/>
-              </a:lnSpc>
-              <a:spcBef>
-                <a:spcPts val="0"/>
-              </a:spcBef>
-              <a:spcAft>
-                <a:spcPts val="0"/>
-              </a:spcAft>
-              <a:buClr>
-                <a:srgbClr val="D2D8E3"/>
-              </a:buClr>
-              <a:buSzPts val="1950"/>
-              <a:buFont typeface="Manrope"/>
-              <a:buNone/>
-            </a:pPr>
-            <a:r>
-              <a:rPr b="0" i="0" lang="en-US" sz="1950" u="none" cap="none" strike="noStrike">
-                <a:solidFill>
-                  <a:srgbClr val="D2D8E3"/>
-                </a:solidFill>
-                <a:latin typeface="Manrope"/>
-                <a:ea typeface="Manrope"/>
-                <a:cs typeface="Manrope"/>
-                <a:sym typeface="Manrope"/>
-              </a:rPr>
-              <a:t>A impulsio opera dentro da conta de vocês. Nada fica hospedado conosco.</a:t>
-            </a:r>
-            <a:endParaRPr b="0" i="0" sz="1400" u="none" cap="none" strike="noStrike">
-              <a:solidFill>
-                <a:srgbClr val="000000"/>
-              </a:solidFill>
-              <a:latin typeface="Arial"/>
-              <a:ea typeface="Arial"/>
-              <a:cs typeface="Arial"/>
-              <a:sym typeface="Arial"/>
-            </a:endParaRPr>
-          </a:p>
-        </p:txBody>
-      </p:sp>
-      <p:sp>
-        <p:nvSpPr>
-          <p:cNvPr id="181" name="Google Shape;181;p14"/>
-          <p:cNvSpPr/>
-          <p:nvPr/>
-        </p:nvSpPr>
-        <p:spPr>
-          <a:xfrm>
-            <a:off x="762000" y="4714875"/>
-            <a:ext cx="2190750" cy="171450"/>
-          </a:xfrm>
-          <a:prstGeom prst="rect">
-            <a:avLst/>
-          </a:prstGeom>
-          <a:noFill/>
-          <a:ln>
-            <a:noFill/>
-          </a:ln>
-        </p:spPr>
-        <p:txBody>
-          <a:bodyPr anchorCtr="0" anchor="t" bIns="0" lIns="0" spcFirstLastPara="1" rIns="0" wrap="square" tIns="0">
-            <a:noAutofit/>
-          </a:bodyPr>
-          <a:lstStyle/>
-          <a:p>
-            <a:pPr indent="0" lvl="0" marL="0" marR="0" rtl="0" algn="l">
-              <a:lnSpc>
-                <a:spcPct val="100000"/>
-              </a:lnSpc>
-              <a:spcBef>
-                <a:spcPts val="0"/>
-              </a:spcBef>
-              <a:spcAft>
-                <a:spcPts val="0"/>
-              </a:spcAft>
-              <a:buClr>
-                <a:srgbClr val="B5CBF5"/>
-              </a:buClr>
-              <a:buSzPts val="1350"/>
-              <a:buFont typeface="JetBrains Mono"/>
-              <a:buNone/>
-            </a:pPr>
-            <a:r>
-              <a:rPr b="0" i="0" lang="en-US" sz="1350" u="none" cap="none" strike="noStrike">
-                <a:solidFill>
-                  <a:srgbClr val="B5CBF5"/>
-                </a:solidFill>
-                <a:latin typeface="JetBrains Mono"/>
-                <a:ea typeface="JetBrains Mono"/>
-                <a:cs typeface="JetBrains Mono"/>
-                <a:sym typeface="JetBrains Mono"/>
-              </a:rPr>
-              <a:t>NA SAÍDA</a:t>
-            </a:r>
-            <a:endParaRPr b="0" i="0" sz="1400" u="none" cap="none" strike="noStrike">
-              <a:solidFill>
-                <a:srgbClr val="000000"/>
-              </a:solidFill>
-              <a:latin typeface="Arial"/>
-              <a:ea typeface="Arial"/>
-              <a:cs typeface="Arial"/>
-              <a:sym typeface="Arial"/>
-            </a:endParaRPr>
-          </a:p>
-        </p:txBody>
-      </p:sp>
-      <p:sp>
-        <p:nvSpPr>
-          <p:cNvPr id="182" name="Google Shape;182;p14"/>
-          <p:cNvSpPr/>
-          <p:nvPr/>
-        </p:nvSpPr>
-        <p:spPr>
-          <a:xfrm>
-            <a:off x="3143250" y="4505325"/>
-            <a:ext cx="8286750" cy="476250"/>
-          </a:xfrm>
-          <a:prstGeom prst="rect">
-            <a:avLst/>
-          </a:prstGeom>
-          <a:noFill/>
-          <a:ln>
-            <a:noFill/>
-          </a:ln>
-        </p:spPr>
-        <p:txBody>
-          <a:bodyPr anchorCtr="0" anchor="t" bIns="0" lIns="0" spcFirstLastPara="1" rIns="0" wrap="square" tIns="0">
-            <a:noAutofit/>
-          </a:bodyPr>
-          <a:lstStyle/>
-          <a:p>
-            <a:pPr indent="0" lvl="0" marL="0" marR="0" rtl="0" algn="l">
-              <a:lnSpc>
-                <a:spcPct val="100000"/>
-              </a:lnSpc>
-              <a:spcBef>
-                <a:spcPts val="0"/>
-              </a:spcBef>
-              <a:spcAft>
-                <a:spcPts val="0"/>
-              </a:spcAft>
-              <a:buClr>
-                <a:srgbClr val="69A7FF"/>
-              </a:buClr>
-              <a:buSzPts val="3750"/>
-              <a:buFont typeface="Space Grotesk"/>
-              <a:buNone/>
-            </a:pPr>
-            <a:r>
-              <a:rPr b="1" i="0" lang="en-US" sz="3750" u="none" cap="none" strike="noStrike">
-                <a:solidFill>
-                  <a:srgbClr val="69A7FF"/>
-                </a:solidFill>
-                <a:latin typeface="Space Grotesk"/>
-                <a:ea typeface="Space Grotesk"/>
-                <a:cs typeface="Space Grotesk"/>
-                <a:sym typeface="Space Grotesk"/>
-              </a:rPr>
-              <a:t>Entrega em 15 dias</a:t>
-            </a:r>
-            <a:endParaRPr b="0" i="0" sz="1400" u="none" cap="none" strike="noStrike">
-              <a:solidFill>
-                <a:srgbClr val="000000"/>
-              </a:solidFill>
-              <a:latin typeface="Arial"/>
-              <a:ea typeface="Arial"/>
-              <a:cs typeface="Arial"/>
-              <a:sym typeface="Arial"/>
-            </a:endParaRPr>
-          </a:p>
-        </p:txBody>
-      </p:sp>
-      <p:sp>
-        <p:nvSpPr>
-          <p:cNvPr id="183" name="Google Shape;183;p14"/>
-          <p:cNvSpPr/>
-          <p:nvPr/>
-        </p:nvSpPr>
-        <p:spPr>
-          <a:xfrm>
-            <a:off x="3181350" y="5219700"/>
-            <a:ext cx="8248650" cy="495300"/>
-          </a:xfrm>
-          <a:prstGeom prst="rect">
-            <a:avLst/>
-          </a:prstGeom>
-          <a:noFill/>
-          <a:ln>
-            <a:noFill/>
-          </a:ln>
-        </p:spPr>
-        <p:txBody>
-          <a:bodyPr anchorCtr="0" anchor="t" bIns="0" lIns="0" spcFirstLastPara="1" rIns="0" wrap="square" tIns="0">
-            <a:noAutofit/>
-          </a:bodyPr>
-          <a:lstStyle/>
-          <a:p>
-            <a:pPr indent="0" lvl="0" marL="0" marR="0" rtl="0" algn="l">
-              <a:lnSpc>
-                <a:spcPct val="100000"/>
-              </a:lnSpc>
-              <a:spcBef>
-                <a:spcPts val="0"/>
-              </a:spcBef>
-              <a:spcAft>
-                <a:spcPts val="0"/>
-              </a:spcAft>
-              <a:buClr>
-                <a:srgbClr val="D2D8E3"/>
-              </a:buClr>
-              <a:buSzPts val="1950"/>
-              <a:buFont typeface="Manrope"/>
-              <a:buNone/>
-            </a:pPr>
-            <a:r>
-              <a:rPr b="0" i="0" lang="en-US" sz="1950" u="none" cap="none" strike="noStrike">
-                <a:solidFill>
-                  <a:srgbClr val="D2D8E3"/>
-                </a:solidFill>
-                <a:latin typeface="Manrope"/>
-                <a:ea typeface="Manrope"/>
-                <a:cs typeface="Manrope"/>
-                <a:sym typeface="Manrope"/>
-              </a:rPr>
-              <a:t>Acessos, fichas, conteúdo, padrão e planilha de controle ficam com a</a:t>
-            </a:r>
-            <a:endParaRPr b="0" i="0" sz="1400" u="none" cap="none" strike="noStrike">
-              <a:solidFill>
-                <a:srgbClr val="000000"/>
-              </a:solidFill>
-              <a:latin typeface="Arial"/>
-              <a:ea typeface="Arial"/>
-              <a:cs typeface="Arial"/>
-              <a:sym typeface="Arial"/>
-            </a:endParaRPr>
-          </a:p>
-          <a:p>
-            <a:pPr indent="0" lvl="0" marL="0" marR="0" rtl="0" algn="l">
-              <a:lnSpc>
-                <a:spcPct val="100000"/>
-              </a:lnSpc>
-              <a:spcBef>
-                <a:spcPts val="0"/>
-              </a:spcBef>
-              <a:spcAft>
-                <a:spcPts val="0"/>
-              </a:spcAft>
-              <a:buClr>
-                <a:srgbClr val="D2D8E3"/>
-              </a:buClr>
-              <a:buSzPts val="1950"/>
-              <a:buFont typeface="Manrope"/>
-              <a:buNone/>
-            </a:pPr>
-            <a:r>
-              <a:rPr b="0" i="0" lang="en-US" sz="1950" u="none" cap="none" strike="noStrike">
-                <a:solidFill>
-                  <a:srgbClr val="D2D8E3"/>
-                </a:solidFill>
-                <a:latin typeface="Manrope"/>
-                <a:ea typeface="Manrope"/>
-                <a:cs typeface="Manrope"/>
-                <a:sym typeface="Manrope"/>
-              </a:rPr>
-              <a:t>Still Pet, sem retenção de nada.</a:t>
-            </a:r>
-            <a:endParaRPr b="0" i="0" sz="1400" u="none" cap="none" strike="noStrike">
-              <a:solidFill>
-                <a:srgbClr val="000000"/>
-              </a:solidFill>
-              <a:latin typeface="Arial"/>
-              <a:ea typeface="Arial"/>
-              <a:cs typeface="Arial"/>
-              <a:sym typeface="Arial"/>
             </a:endParaRPr>
           </a:p>
         </p:txBody>
@@ -10850,7 +9586,7 @@
                 <a:cs typeface="JetBrains Mono"/>
                 <a:sym typeface="JetBrains Mono"/>
               </a:rPr>
-              <a:t>11 / 11</a:t>
+              <a:t>10 / 10</a:t>
             </a:r>
             <a:endParaRPr b="0" i="0" sz="1400" u="none" cap="none" strike="noStrike">
               <a:solidFill>
@@ -12316,7 +11052,7 @@
                 <a:cs typeface="JetBrains Mono"/>
                 <a:sym typeface="JetBrains Mono"/>
               </a:rPr>
-              <a:t>02 / 11</a:t>
+              <a:t>02 / 10</a:t>
             </a:r>
             <a:endParaRPr b="0" i="0" sz="1400" u="none" cap="none" strike="noStrike">
               <a:solidFill>
@@ -12998,7 +11734,7 @@
                 <a:cs typeface="JetBrains Mono"/>
                 <a:sym typeface="JetBrains Mono"/>
               </a:rPr>
-              <a:t>03 / 11</a:t>
+              <a:t>03 / 10</a:t>
             </a:r>
             <a:endParaRPr b="0" i="0" sz="1400" u="none" cap="none" strike="noStrike">
               <a:solidFill>
@@ -14064,7 +12800,7 @@
                 <a:cs typeface="JetBrains Mono"/>
                 <a:sym typeface="JetBrains Mono"/>
               </a:rPr>
-              <a:t>04 / 11</a:t>
+              <a:t>04 / 10</a:t>
             </a:r>
             <a:endParaRPr b="0" i="0" sz="1400" u="none" cap="none" strike="noStrike">
               <a:solidFill>
@@ -15068,7 +13804,7 @@
                 <a:cs typeface="JetBrains Mono"/>
                 <a:sym typeface="JetBrains Mono"/>
               </a:rPr>
-              <a:t>05 / 11</a:t>
+              <a:t>05 / 10</a:t>
             </a:r>
             <a:endParaRPr b="0" i="0" sz="1400" u="none" cap="none" strike="noStrike">
               <a:solidFill>
@@ -16098,7 +14834,7 @@
                 <a:cs typeface="JetBrains Mono"/>
                 <a:sym typeface="JetBrains Mono"/>
               </a:rPr>
-              <a:t>06 / 11</a:t>
+              <a:t>06 / 10</a:t>
             </a:r>
             <a:endParaRPr b="0" i="0" sz="1400" u="none" cap="none" strike="noStrike">
               <a:solidFill>
@@ -17348,7 +16084,7 @@
                 <a:cs typeface="JetBrains Mono"/>
                 <a:sym typeface="JetBrains Mono"/>
               </a:rPr>
-              <a:t>07 / 11</a:t>
+              <a:t>07 / 10</a:t>
             </a:r>
             <a:endParaRPr b="0" i="0" sz="1400" u="none" cap="none" strike="noStrike">
               <a:solidFill>
@@ -18562,7 +17298,7 @@
                 <a:cs typeface="JetBrains Mono"/>
                 <a:sym typeface="JetBrains Mono"/>
               </a:rPr>
-              <a:t>08 / 11</a:t>
+              <a:t>08 / 10</a:t>
             </a:r>
             <a:endParaRPr b="0" i="0" sz="1400" u="none" cap="none" strike="noStrike">
               <a:solidFill>
@@ -19818,7 +18554,7 @@
                 <a:cs typeface="JetBrains Mono"/>
                 <a:sym typeface="JetBrains Mono"/>
               </a:rPr>
-              <a:t>09 / 11</a:t>
+              <a:t>09 / 10</a:t>
             </a:r>
             <a:endParaRPr b="0" i="0" sz="1400" u="none" cap="none" strike="noStrike">
               <a:solidFill>

</xml_diff>